<commit_message>
Last before modifying the structure of the dataset used to comply with the standard one
</commit_message>
<xml_diff>
--- a/Schémas et formules mathématiques.pptx
+++ b/Schémas et formules mathématiques.pptx
@@ -307,7 +307,7 @@
           <a:p>
             <a:fld id="{8CC8168F-B74C-4525-A6F8-EBA84798C097}" type="datetimeFigureOut">
               <a:rPr lang="fr-FR" smtClean="0"/>
-              <a:t>02/06/2025</a:t>
+              <a:t>09/06/2025</a:t>
             </a:fld>
             <a:endParaRPr lang="fr-FR"/>
           </a:p>
@@ -505,7 +505,7 @@
           <a:p>
             <a:fld id="{8CC8168F-B74C-4525-A6F8-EBA84798C097}" type="datetimeFigureOut">
               <a:rPr lang="fr-FR" smtClean="0"/>
-              <a:t>02/06/2025</a:t>
+              <a:t>09/06/2025</a:t>
             </a:fld>
             <a:endParaRPr lang="fr-FR"/>
           </a:p>
@@ -713,7 +713,7 @@
           <a:p>
             <a:fld id="{8CC8168F-B74C-4525-A6F8-EBA84798C097}" type="datetimeFigureOut">
               <a:rPr lang="fr-FR" smtClean="0"/>
-              <a:t>02/06/2025</a:t>
+              <a:t>09/06/2025</a:t>
             </a:fld>
             <a:endParaRPr lang="fr-FR"/>
           </a:p>
@@ -911,7 +911,7 @@
           <a:p>
             <a:fld id="{8CC8168F-B74C-4525-A6F8-EBA84798C097}" type="datetimeFigureOut">
               <a:rPr lang="fr-FR" smtClean="0"/>
-              <a:t>02/06/2025</a:t>
+              <a:t>09/06/2025</a:t>
             </a:fld>
             <a:endParaRPr lang="fr-FR"/>
           </a:p>
@@ -1186,7 +1186,7 @@
           <a:p>
             <a:fld id="{8CC8168F-B74C-4525-A6F8-EBA84798C097}" type="datetimeFigureOut">
               <a:rPr lang="fr-FR" smtClean="0"/>
-              <a:t>02/06/2025</a:t>
+              <a:t>09/06/2025</a:t>
             </a:fld>
             <a:endParaRPr lang="fr-FR"/>
           </a:p>
@@ -1451,7 +1451,7 @@
           <a:p>
             <a:fld id="{8CC8168F-B74C-4525-A6F8-EBA84798C097}" type="datetimeFigureOut">
               <a:rPr lang="fr-FR" smtClean="0"/>
-              <a:t>02/06/2025</a:t>
+              <a:t>09/06/2025</a:t>
             </a:fld>
             <a:endParaRPr lang="fr-FR"/>
           </a:p>
@@ -1863,7 +1863,7 @@
           <a:p>
             <a:fld id="{8CC8168F-B74C-4525-A6F8-EBA84798C097}" type="datetimeFigureOut">
               <a:rPr lang="fr-FR" smtClean="0"/>
-              <a:t>02/06/2025</a:t>
+              <a:t>09/06/2025</a:t>
             </a:fld>
             <a:endParaRPr lang="fr-FR"/>
           </a:p>
@@ -2004,7 +2004,7 @@
           <a:p>
             <a:fld id="{8CC8168F-B74C-4525-A6F8-EBA84798C097}" type="datetimeFigureOut">
               <a:rPr lang="fr-FR" smtClean="0"/>
-              <a:t>02/06/2025</a:t>
+              <a:t>09/06/2025</a:t>
             </a:fld>
             <a:endParaRPr lang="fr-FR"/>
           </a:p>
@@ -2117,7 +2117,7 @@
           <a:p>
             <a:fld id="{8CC8168F-B74C-4525-A6F8-EBA84798C097}" type="datetimeFigureOut">
               <a:rPr lang="fr-FR" smtClean="0"/>
-              <a:t>02/06/2025</a:t>
+              <a:t>09/06/2025</a:t>
             </a:fld>
             <a:endParaRPr lang="fr-FR"/>
           </a:p>
@@ -2428,7 +2428,7 @@
           <a:p>
             <a:fld id="{8CC8168F-B74C-4525-A6F8-EBA84798C097}" type="datetimeFigureOut">
               <a:rPr lang="fr-FR" smtClean="0"/>
-              <a:t>02/06/2025</a:t>
+              <a:t>09/06/2025</a:t>
             </a:fld>
             <a:endParaRPr lang="fr-FR"/>
           </a:p>
@@ -2716,7 +2716,7 @@
           <a:p>
             <a:fld id="{8CC8168F-B74C-4525-A6F8-EBA84798C097}" type="datetimeFigureOut">
               <a:rPr lang="fr-FR" smtClean="0"/>
-              <a:t>02/06/2025</a:t>
+              <a:t>09/06/2025</a:t>
             </a:fld>
             <a:endParaRPr lang="fr-FR"/>
           </a:p>
@@ -2957,7 +2957,7 @@
           <a:p>
             <a:fld id="{8CC8168F-B74C-4525-A6F8-EBA84798C097}" type="datetimeFigureOut">
               <a:rPr lang="fr-FR" smtClean="0"/>
-              <a:t>02/06/2025</a:t>
+              <a:t>09/06/2025</a:t>
             </a:fld>
             <a:endParaRPr lang="fr-FR"/>
           </a:p>
@@ -18381,9 +18381,16 @@
             <p:ph idx="1"/>
           </p:nvPr>
         </p:nvSpPr>
-        <p:spPr/>
+        <p:spPr>
+          <a:xfrm>
+            <a:off x="838200" y="1825624"/>
+            <a:ext cx="10515600" cy="4721479"/>
+          </a:xfrm>
+        </p:spPr>
         <p:txBody>
-          <a:bodyPr/>
+          <a:bodyPr>
+            <a:normAutofit fontScale="62500" lnSpcReduction="20000"/>
+          </a:bodyPr>
           <a:lstStyle/>
           <a:p>
             <a:pPr marL="0" indent="0">
@@ -18402,10 +18409,105 @@
               <a:t> (dans l’ordre de calcul) couche. Il faut juste avoir rentré les dérivées partielles du coût par rapport aux valeurs de la dernière couche :</a:t>
             </a:r>
           </a:p>
+          <a:p>
+            <a:pPr marL="0" indent="0">
+              <a:buNone/>
+            </a:pPr>
+            <a:endParaRPr lang="fr-FR" dirty="0"/>
+          </a:p>
+          <a:p>
+            <a:pPr marL="0" indent="0">
+              <a:buNone/>
+            </a:pPr>
+            <a:endParaRPr lang="fr-FR" dirty="0"/>
+          </a:p>
+          <a:p>
+            <a:pPr marL="0" indent="0">
+              <a:buNone/>
+            </a:pPr>
+            <a:endParaRPr lang="fr-FR" dirty="0"/>
+          </a:p>
+          <a:p>
+            <a:pPr marL="0" indent="0">
+              <a:buNone/>
+            </a:pPr>
+            <a:endParaRPr lang="fr-FR" dirty="0"/>
+          </a:p>
+          <a:p>
+            <a:pPr marL="0" indent="0">
+              <a:buNone/>
+            </a:pPr>
+            <a:endParaRPr lang="fr-FR" dirty="0"/>
+          </a:p>
+          <a:p>
+            <a:pPr marL="0" indent="0">
+              <a:buNone/>
+            </a:pPr>
+            <a:endParaRPr lang="fr-FR" dirty="0"/>
+          </a:p>
+          <a:p>
+            <a:pPr marL="0" indent="0">
+              <a:buNone/>
+            </a:pPr>
+            <a:endParaRPr lang="fr-FR" dirty="0"/>
+          </a:p>
+          <a:p>
+            <a:pPr marL="0" indent="0">
+              <a:buNone/>
+            </a:pPr>
+            <a:endParaRPr lang="fr-FR" dirty="0"/>
+          </a:p>
+          <a:p>
+            <a:pPr marL="0" indent="0">
+              <a:buNone/>
+            </a:pPr>
+            <a:endParaRPr lang="fr-FR" dirty="0"/>
+          </a:p>
+          <a:p>
+            <a:pPr marL="0" indent="0">
+              <a:buNone/>
+            </a:pPr>
+            <a:r>
+              <a:rPr lang="fr-FR" dirty="0"/>
+              <a:t>et ce sont des vecteurs lignes de mémoire, donc à priori, si je veux paralléliser, il faut les stocker parallèlement, donc dans le sens de la hauteur ? Voyons voir si c’est possible. Ne devrais-je pas plutôt m’y mettre ? Oui, obtenir un </a:t>
+            </a:r>
+            <a:r>
+              <a:rPr lang="fr-FR" dirty="0" err="1"/>
+              <a:t>mvp</a:t>
+            </a:r>
+            <a:r>
+              <a:rPr lang="fr-FR" dirty="0"/>
+              <a:t> d’abord. Juste regardons. </a:t>
+            </a:r>
+            <a:r>
+              <a:rPr lang="fr-FR" dirty="0" err="1"/>
+              <a:t>Mmh</a:t>
+            </a:r>
+            <a:r>
+              <a:rPr lang="fr-FR" dirty="0"/>
+              <a:t>, il me semble que ça marchera, mais que ça </a:t>
+            </a:r>
+            <a:r>
+              <a:rPr lang="fr-FR" dirty="0" err="1"/>
+              <a:t>nécéssitera</a:t>
+            </a:r>
+            <a:r>
+              <a:rPr lang="fr-FR" dirty="0"/>
+              <a:t> de manipuler des tenseurs de dimension 3. Attendre d’implémenter </a:t>
+            </a:r>
+            <a:r>
+              <a:rPr lang="fr-FR" dirty="0" err="1"/>
+              <a:t>pytorch</a:t>
+            </a:r>
+            <a:r>
+              <a:rPr lang="fr-FR" dirty="0"/>
+              <a:t> donc.</a:t>
+            </a:r>
+          </a:p>
         </p:txBody>
       </p:sp>
-      <mc:AlternateContent xmlns:mc="http://schemas.openxmlformats.org/markup-compatibility/2006" xmlns:a14="http://schemas.microsoft.com/office/drawing/2010/main">
-        <mc:Choice Requires="a14">
+      <mc:AlternateContent xmlns:mc="http://schemas.openxmlformats.org/markup-compatibility/2006">
+        <mc:Choice xmlns:a14="http://schemas.microsoft.com/office/drawing/2010/main" Requires="a14">
           <p:sp>
             <p:nvSpPr>
               <p:cNvPr id="93" name="ZoneTexte 92">
@@ -18421,7 +18523,7 @@
             <p:spPr>
               <a:xfrm>
                 <a:off x="4789170" y="3405363"/>
-                <a:ext cx="3116622" cy="1345176"/>
+                <a:ext cx="3536609" cy="2325701"/>
               </a:xfrm>
               <a:prstGeom prst="rect">
                 <a:avLst/>
@@ -18782,7 +18884,19 @@
                       <a:rPr lang="fr-FR" b="0" i="1" smtClean="0">
                         <a:latin typeface="Cambria Math" panose="02040503050406030204" pitchFamily="18" charset="0"/>
                       </a:rPr>
-                      <m:t> (</m:t>
+                      <m:t> </m:t>
+                    </m:r>
+                    <m:r>
+                      <a:rPr lang="fr-FR" b="0" i="1" smtClean="0">
+                        <a:latin typeface="Cambria Math" panose="02040503050406030204" pitchFamily="18" charset="0"/>
+                      </a:rPr>
+                      <m:t>   </m:t>
+                    </m:r>
+                    <m:r>
+                      <a:rPr lang="fr-FR" b="0" i="1" smtClean="0">
+                        <a:latin typeface="Cambria Math" panose="02040503050406030204" pitchFamily="18" charset="0"/>
+                      </a:rPr>
+                      <m:t>(</m:t>
                     </m:r>
                     <m:r>
                       <a:rPr lang="fr-FR" b="0" i="1" smtClean="0">
@@ -18806,10 +18920,242 @@
               <a:p>
                 <a:endParaRPr lang="fr-FR" dirty="0"/>
               </a:p>
+              <a:p>
+                <a14:m>
+                  <m:oMath xmlns:m="http://schemas.openxmlformats.org/officeDocument/2006/math">
+                    <m:f>
+                      <m:fPr>
+                        <m:ctrlPr>
+                          <a:rPr lang="fr-FR" i="1">
+                            <a:latin typeface="Cambria Math" panose="02040503050406030204" pitchFamily="18" charset="0"/>
+                          </a:rPr>
+                        </m:ctrlPr>
+                      </m:fPr>
+                      <m:num>
+                        <m:r>
+                          <a:rPr lang="fr-FR" i="1">
+                            <a:latin typeface="Cambria Math" panose="02040503050406030204" pitchFamily="18" charset="0"/>
+                          </a:rPr>
+                          <m:t>𝜕</m:t>
+                        </m:r>
+                        <m:sSub>
+                          <m:sSubPr>
+                            <m:ctrlPr>
+                              <a:rPr lang="fr-FR" i="1">
+                                <a:latin typeface="Cambria Math" panose="02040503050406030204" pitchFamily="18" charset="0"/>
+                              </a:rPr>
+                            </m:ctrlPr>
+                          </m:sSubPr>
+                          <m:e>
+                            <m:r>
+                              <a:rPr lang="fr-FR" i="1">
+                                <a:latin typeface="Cambria Math" panose="02040503050406030204" pitchFamily="18" charset="0"/>
+                              </a:rPr>
+                              <m:t>𝐶</m:t>
+                            </m:r>
+                          </m:e>
+                          <m:sub>
+                            <m:r>
+                              <a:rPr lang="fr-FR" i="1">
+                                <a:latin typeface="Cambria Math" panose="02040503050406030204" pitchFamily="18" charset="0"/>
+                              </a:rPr>
+                              <m:t>/</m:t>
+                            </m:r>
+                            <m:r>
+                              <a:rPr lang="fr-FR" i="1">
+                                <a:latin typeface="Cambria Math" panose="02040503050406030204" pitchFamily="18" charset="0"/>
+                              </a:rPr>
+                              <m:t>𝑖𝑚𝑎𝑔𝑒</m:t>
+                            </m:r>
+                            <m:r>
+                              <a:rPr lang="fr-FR" b="0" i="1" smtClean="0">
+                                <a:latin typeface="Cambria Math" panose="02040503050406030204" pitchFamily="18" charset="0"/>
+                              </a:rPr>
+                              <m:t>_</m:t>
+                            </m:r>
+                            <m:r>
+                              <a:rPr lang="fr-FR" b="0" i="1" smtClean="0">
+                                <a:latin typeface="Cambria Math" panose="02040503050406030204" pitchFamily="18" charset="0"/>
+                              </a:rPr>
+                              <m:t>𝑙</m:t>
+                            </m:r>
+                          </m:sub>
+                        </m:sSub>
+                      </m:num>
+                      <m:den>
+                        <m:r>
+                          <a:rPr lang="fr-FR" i="1">
+                            <a:latin typeface="Cambria Math" panose="02040503050406030204" pitchFamily="18" charset="0"/>
+                          </a:rPr>
+                          <m:t>𝜕</m:t>
+                        </m:r>
+                        <m:sSup>
+                          <m:sSupPr>
+                            <m:ctrlPr>
+                              <a:rPr lang="fr-FR" i="1">
+                                <a:latin typeface="Cambria Math" panose="02040503050406030204" pitchFamily="18" charset="0"/>
+                              </a:rPr>
+                            </m:ctrlPr>
+                          </m:sSupPr>
+                          <m:e>
+                            <m:r>
+                              <a:rPr lang="fr-FR" i="1">
+                                <a:latin typeface="Cambria Math" panose="02040503050406030204" pitchFamily="18" charset="0"/>
+                              </a:rPr>
+                              <m:t>𝐴</m:t>
+                            </m:r>
+                          </m:e>
+                          <m:sup>
+                            <m:r>
+                              <a:rPr lang="fr-FR" i="1">
+                                <a:latin typeface="Cambria Math" panose="02040503050406030204" pitchFamily="18" charset="0"/>
+                              </a:rPr>
+                              <m:t>𝑁</m:t>
+                            </m:r>
+                            <m:r>
+                              <a:rPr lang="fr-FR" i="1">
+                                <a:latin typeface="Cambria Math" panose="02040503050406030204" pitchFamily="18" charset="0"/>
+                              </a:rPr>
+                              <m:t>−1</m:t>
+                            </m:r>
+                          </m:sup>
+                        </m:sSup>
+                      </m:den>
+                    </m:f>
+                    <m:r>
+                      <a:rPr lang="fr-FR" i="1">
+                        <a:latin typeface="Cambria Math" panose="02040503050406030204" pitchFamily="18" charset="0"/>
+                      </a:rPr>
+                      <m:t>=−2 ∗</m:t>
+                    </m:r>
+                    <m:d>
+                      <m:dPr>
+                        <m:ctrlPr>
+                          <a:rPr lang="fr-FR" i="1">
+                            <a:latin typeface="Cambria Math" panose="02040503050406030204" pitchFamily="18" charset="0"/>
+                          </a:rPr>
+                        </m:ctrlPr>
+                      </m:dPr>
+                      <m:e>
+                        <m:sSub>
+                          <m:sSubPr>
+                            <m:ctrlPr>
+                              <a:rPr lang="fr-FR" i="1" smtClean="0">
+                                <a:latin typeface="Cambria Math" panose="02040503050406030204" pitchFamily="18" charset="0"/>
+                              </a:rPr>
+                            </m:ctrlPr>
+                          </m:sSubPr>
+                          <m:e>
+                            <m:r>
+                              <a:rPr lang="fr-FR" b="0" i="1" smtClean="0">
+                                <a:latin typeface="Cambria Math" panose="02040503050406030204" pitchFamily="18" charset="0"/>
+                              </a:rPr>
+                              <m:t>𝑦</m:t>
+                            </m:r>
+                          </m:e>
+                          <m:sub>
+                            <m:r>
+                              <a:rPr lang="fr-FR" b="0" i="1" smtClean="0">
+                                <a:latin typeface="Cambria Math" panose="02040503050406030204" pitchFamily="18" charset="0"/>
+                              </a:rPr>
+                              <m:t>/</m:t>
+                            </m:r>
+                            <m:r>
+                              <a:rPr lang="fr-FR" b="0" i="1" smtClean="0">
+                                <a:latin typeface="Cambria Math" panose="02040503050406030204" pitchFamily="18" charset="0"/>
+                              </a:rPr>
+                              <m:t>𝑙</m:t>
+                            </m:r>
+                          </m:sub>
+                        </m:sSub>
+                        <m:r>
+                          <a:rPr lang="fr-FR" i="1">
+                            <a:latin typeface="Cambria Math" panose="02040503050406030204" pitchFamily="18" charset="0"/>
+                          </a:rPr>
+                          <m:t>−</m:t>
+                        </m:r>
+                        <m:sSubSup>
+                          <m:sSubSupPr>
+                            <m:ctrlPr>
+                              <a:rPr lang="fr-FR" i="1" smtClean="0">
+                                <a:latin typeface="Cambria Math" panose="02040503050406030204" pitchFamily="18" charset="0"/>
+                              </a:rPr>
+                            </m:ctrlPr>
+                          </m:sSubSupPr>
+                          <m:e>
+                            <m:r>
+                              <a:rPr lang="fr-FR" b="0" i="1" smtClean="0">
+                                <a:latin typeface="Cambria Math" panose="02040503050406030204" pitchFamily="18" charset="0"/>
+                              </a:rPr>
+                              <m:t>𝐴</m:t>
+                            </m:r>
+                          </m:e>
+                          <m:sub>
+                            <m:r>
+                              <a:rPr lang="fr-FR" b="0" i="1" smtClean="0">
+                                <a:latin typeface="Cambria Math" panose="02040503050406030204" pitchFamily="18" charset="0"/>
+                              </a:rPr>
+                              <m:t>/</m:t>
+                            </m:r>
+                            <m:r>
+                              <a:rPr lang="fr-FR" b="0" i="1" smtClean="0">
+                                <a:latin typeface="Cambria Math" panose="02040503050406030204" pitchFamily="18" charset="0"/>
+                              </a:rPr>
+                              <m:t>𝑙</m:t>
+                            </m:r>
+                          </m:sub>
+                          <m:sup>
+                            <m:r>
+                              <a:rPr lang="fr-FR" b="0" i="1" smtClean="0">
+                                <a:latin typeface="Cambria Math" panose="02040503050406030204" pitchFamily="18" charset="0"/>
+                              </a:rPr>
+                              <m:t>𝑁</m:t>
+                            </m:r>
+                            <m:r>
+                              <a:rPr lang="fr-FR" b="0" i="1" smtClean="0">
+                                <a:latin typeface="Cambria Math" panose="02040503050406030204" pitchFamily="18" charset="0"/>
+                              </a:rPr>
+                              <m:t>−1</m:t>
+                            </m:r>
+                          </m:sup>
+                        </m:sSubSup>
+                      </m:e>
+                    </m:d>
+                    <m:r>
+                      <a:rPr lang="fr-FR" i="1">
+                        <a:latin typeface="Cambria Math" panose="02040503050406030204" pitchFamily="18" charset="0"/>
+                      </a:rPr>
+                      <m:t>    (</m:t>
+                    </m:r>
+                    <m:r>
+                      <a:rPr lang="fr-FR" i="1">
+                        <a:latin typeface="Cambria Math" panose="02040503050406030204" pitchFamily="18" charset="0"/>
+                      </a:rPr>
+                      <m:t>𝑙</m:t>
+                    </m:r>
+                    <m:r>
+                      <a:rPr lang="fr-FR" i="1">
+                        <a:latin typeface="Cambria Math" panose="02040503050406030204" pitchFamily="18" charset="0"/>
+                      </a:rPr>
+                      <m:t>)</m:t>
+                    </m:r>
+                  </m:oMath>
+                </a14:m>
+                <a:r>
+                  <a:rPr lang="fr-FR" dirty="0"/>
+                  <a:t> </a:t>
+                </a:r>
+              </a:p>
+              <a:p>
+                <a:endParaRPr lang="fr-FR" dirty="0"/>
+              </a:p>
+              <a:p>
+                <a:endParaRPr lang="fr-FR" dirty="0"/>
+              </a:p>
             </p:txBody>
           </p:sp>
         </mc:Choice>
-        <mc:Fallback xmlns="">
+        <mc:Fallback>
           <p:sp>
             <p:nvSpPr>
               <p:cNvPr id="93" name="ZoneTexte 92">
@@ -18827,7 +19173,7 @@
             <p:spPr>
               <a:xfrm>
                 <a:off x="4789170" y="3405363"/>
-                <a:ext cx="3116622" cy="1345176"/>
+                <a:ext cx="3536609" cy="2325701"/>
               </a:xfrm>
               <a:prstGeom prst="rect">
                 <a:avLst/>
@@ -18835,7 +19181,7 @@
               <a:blipFill>
                 <a:blip r:embed="rId2"/>
                 <a:stretch>
-                  <a:fillRect l="-196"/>
+                  <a:fillRect l="-172"/>
                 </a:stretch>
               </a:blipFill>
             </p:spPr>
@@ -20030,8 +20376,8 @@
           </p:sp>
         </mc:Fallback>
       </mc:AlternateContent>
-      <mc:AlternateContent xmlns:mc="http://schemas.openxmlformats.org/markup-compatibility/2006">
-        <mc:Choice xmlns:a14="http://schemas.microsoft.com/office/drawing/2010/main" Requires="a14">
+      <mc:AlternateContent xmlns:mc="http://schemas.openxmlformats.org/markup-compatibility/2006" xmlns:a14="http://schemas.microsoft.com/office/drawing/2010/main">
+        <mc:Choice Requires="a14">
           <p:sp>
             <p:nvSpPr>
               <p:cNvPr id="95" name="ZoneTexte 94">
@@ -22567,7 +22913,7 @@
             </p:txBody>
           </p:sp>
         </mc:Choice>
-        <mc:Fallback>
+        <mc:Fallback xmlns="">
           <p:sp>
             <p:nvSpPr>
               <p:cNvPr id="95" name="ZoneTexte 94">
@@ -26234,8 +26580,8 @@
           <a:chExt cx="0" cy="0"/>
         </a:xfrm>
       </p:grpSpPr>
-      <mc:AlternateContent xmlns:mc="http://schemas.openxmlformats.org/markup-compatibility/2006">
-        <mc:Choice xmlns:a14="http://schemas.microsoft.com/office/drawing/2010/main" Requires="a14">
+      <mc:AlternateContent xmlns:mc="http://schemas.openxmlformats.org/markup-compatibility/2006" xmlns:a14="http://schemas.microsoft.com/office/drawing/2010/main">
+        <mc:Choice Requires="a14">
           <p:sp>
             <p:nvSpPr>
               <p:cNvPr id="4" name="ZoneTexte 3">
@@ -26264,6 +26610,7 @@
               </a:bodyPr>
               <a:lstStyle/>
               <a:p>
+                <a:pPr/>
                 <a14:m>
                   <m:oMathPara xmlns:m="http://schemas.openxmlformats.org/officeDocument/2006/math">
                     <m:oMathParaPr>
@@ -26684,6 +27031,7 @@
                 <a:endParaRPr lang="fr-FR" dirty="0"/>
               </a:p>
               <a:p>
+                <a:pPr/>
                 <a14:m>
                   <m:oMathPara xmlns:m="http://schemas.openxmlformats.org/officeDocument/2006/math">
                     <m:oMathParaPr>
@@ -26864,7 +27212,7 @@
             </p:txBody>
           </p:sp>
         </mc:Choice>
-        <mc:Fallback>
+        <mc:Fallback xmlns="">
           <p:sp>
             <p:nvSpPr>
               <p:cNvPr id="4" name="ZoneTexte 3">

</xml_diff>